<commit_message>
Deck: correct TripleDart naming and state EBITDA at 40%
Co-Authored-By: Claude Opus 4.8 <noreply@anthropic.com>
Claude-Session: https://claude.ai/code/session_014oyeDvdHs7BNv6CwTMq2DF
</commit_message>
<xml_diff>
--- a/TripleDart_Slate_Investor_Deck.pptx
+++ b/TripleDart_Slate_Investor_Deck.pptx
@@ -8705,7 +8705,7 @@
                 <a:ea typeface="Calibri" pitchFamily="34" charset="-122"/>
                 <a:cs typeface="Calibri" pitchFamily="34" charset="-120"/>
               </a:rPr>
-              <a:t>EBIT multiple on Triple Dot (~$28–33M)</a:t>
+              <a:t>EBIT multiple on TripleDart (~$28–33M)</a:t>
             </a:r>
             <a:endParaRPr lang="en-US" sz="1050" dirty="0"/>
           </a:p>
@@ -9887,7 +9887,7 @@
                 <a:ea typeface="Century Schoolbook" pitchFamily="34" charset="-122"/>
                 <a:cs typeface="Century Schoolbook" pitchFamily="34" charset="-120"/>
               </a:rPr>
-              <a:t>40%+</a:t>
+              <a:t>40%</a:t>
             </a:r>
             <a:endParaRPr lang="en-US" sz="3000" dirty="0"/>
           </a:p>
@@ -11578,7 +11578,7 @@
                 <a:ea typeface="Calibri" pitchFamily="34" charset="-122"/>
                 <a:cs typeface="Calibri" pitchFamily="34" charset="-120"/>
               </a:rPr>
-              <a:t>Triple Dot — senior operators run your GTM.  $4K–$30K / mo retainers.</a:t>
+              <a:t>TripleDart — senior operators run your GTM.  $4K–$30K / mo retainers.</a:t>
             </a:r>
             <a:endParaRPr lang="en-US" sz="1400" dirty="0"/>
           </a:p>
@@ -12013,7 +12013,7 @@
                 <a:ea typeface="Century Schoolbook" pitchFamily="34" charset="-122"/>
                 <a:cs typeface="Century Schoolbook" pitchFamily="34" charset="-120"/>
               </a:rPr>
-              <a:t>Triple Dot</a:t>
+              <a:t>TripleDart</a:t>
             </a:r>
             <a:endParaRPr lang="en-US" sz="2600" dirty="0"/>
           </a:p>

</xml_diff>